<commit_message>
Auto-generate presentation: alimentos-felicidad.pptx and .pdf
</commit_message>
<xml_diff>
--- a/presentations/alimentos-felicidad/alimentos-felicidad.pptx
+++ b/presentations/alimentos-felicidad/alimentos-felicidad.pptx
@@ -3638,57 +3638,30 @@
           </a:p>
         </p:txBody>
       </p:sp>
-      <p:sp>
-        <p:nvSpPr>
-          <p:cNvPr id="7" name="Rectangle 6"/>
-          <p:cNvSpPr/>
+      <p:pic>
+        <p:nvPicPr>
+          <p:cNvPr id="7" name="Picture 6" descr="Chocolate__28blue_background_29.jpg"/>
+          <p:cNvPicPr>
+            <a:picLocks noChangeAspect="1"/>
+          </p:cNvPicPr>
           <p:nvPr/>
-        </p:nvSpPr>
+        </p:nvPicPr>
+        <p:blipFill>
+          <a:blip r:embed="rId2"/>
+          <a:stretch>
+            <a:fillRect/>
+          </a:stretch>
+        </p:blipFill>
         <p:spPr>
           <a:xfrm>
             <a:off x="7132320" y="1828800"/>
-            <a:ext cx="4023360" cy="3291840"/>
+            <a:ext cx="4023360" cy="3621024"/>
           </a:xfrm>
           <a:prstGeom prst="rect">
             <a:avLst/>
           </a:prstGeom>
-          <a:solidFill>
-            <a:srgbClr val="5A6268"/>
-          </a:solidFill>
-          <a:ln>
-            <a:noFill/>
-          </a:ln>
-        </p:spPr>
-        <p:style>
-          <a:lnRef idx="1">
-            <a:schemeClr val="accent1"/>
-          </a:lnRef>
-          <a:fillRef idx="3">
-            <a:schemeClr val="accent1"/>
-          </a:fillRef>
-          <a:effectRef idx="2">
-            <a:schemeClr val="accent1"/>
-          </a:effectRef>
-          <a:fontRef idx="minor">
-            <a:schemeClr val="lt1"/>
-          </a:fontRef>
-        </p:style>
-        <p:txBody>
-          <a:bodyPr rtlCol="0" anchor="ctr"/>
-          <a:lstStyle/>
-          <a:p>
-            <a:pPr algn="ctr"/>
-            <a:r>
-              <a:rPr sz="2000">
-                <a:solidFill>
-                  <a:srgbClr val="F5F5F5"/>
-                </a:solidFill>
-              </a:rPr>
-              <a:t>Imagen no disponible</a:t>
-            </a:r>
-          </a:p>
-        </p:txBody>
-      </p:sp>
+        </p:spPr>
+      </p:pic>
     </p:spTree>
   </p:cSld>
   <p:clrMapOvr>
@@ -5208,57 +5181,30 @@
           </a:p>
         </p:txBody>
       </p:sp>
-      <p:sp>
-        <p:nvSpPr>
-          <p:cNvPr id="7" name="Rectangle 6"/>
-          <p:cNvSpPr/>
+      <p:pic>
+        <p:nvPicPr>
+          <p:cNvPr id="7" name="Picture 6" descr="Foods__28cropped_29.jpg"/>
+          <p:cNvPicPr>
+            <a:picLocks noChangeAspect="1"/>
+          </p:cNvPicPr>
           <p:nvPr/>
-        </p:nvSpPr>
+        </p:nvPicPr>
+        <p:blipFill>
+          <a:blip r:embed="rId2"/>
+          <a:stretch>
+            <a:fillRect/>
+          </a:stretch>
+        </p:blipFill>
         <p:spPr>
           <a:xfrm>
             <a:off x="7132320" y="1828800"/>
-            <a:ext cx="4023360" cy="3291840"/>
+            <a:ext cx="4023360" cy="4335266"/>
           </a:xfrm>
           <a:prstGeom prst="rect">
             <a:avLst/>
           </a:prstGeom>
-          <a:solidFill>
-            <a:srgbClr val="5A6268"/>
-          </a:solidFill>
-          <a:ln>
-            <a:noFill/>
-          </a:ln>
-        </p:spPr>
-        <p:style>
-          <a:lnRef idx="1">
-            <a:schemeClr val="accent1"/>
-          </a:lnRef>
-          <a:fillRef idx="3">
-            <a:schemeClr val="accent1"/>
-          </a:fillRef>
-          <a:effectRef idx="2">
-            <a:schemeClr val="accent1"/>
-          </a:effectRef>
-          <a:fontRef idx="minor">
-            <a:schemeClr val="lt1"/>
-          </a:fontRef>
-        </p:style>
-        <p:txBody>
-          <a:bodyPr rtlCol="0" anchor="ctr"/>
-          <a:lstStyle/>
-          <a:p>
-            <a:pPr algn="ctr"/>
-            <a:r>
-              <a:rPr sz="2000">
-                <a:solidFill>
-                  <a:srgbClr val="F5F5F5"/>
-                </a:solidFill>
-              </a:rPr>
-              <a:t>Imagen no disponible</a:t>
-            </a:r>
-          </a:p>
-        </p:txBody>
-      </p:sp>
+        </p:spPr>
+      </p:pic>
     </p:spTree>
   </p:cSld>
   <p:clrMapOvr>

</xml_diff>